<commit_message>
M01-W03-L03 분량 기준 보강
훈련 적응의 두 신호 경로(mTOR와 AMPK)와 병행 훈련의 간섭을 덧붙이고
M02-W12-L03으로 연결한다. 22,000자 기준을 넘긴다.

Co-Authored-By: Claude Opus 5 <noreply@anthropic.com>
Claude-Session: https://claude.ai/code/session_01TGVgH4PG4LB6Jq8r4MtGjs
</commit_message>
<xml_diff>
--- a/curriculum/M01/W03/L03/slides.pptx
+++ b/curriculum/M01/W03/L03/slides.pptx
@@ -31,6 +31,8 @@
     <p:sldId id="279" r:id="rId31"/>
     <p:sldId id="280" r:id="rId32"/>
     <p:sldId id="281" r:id="rId33"/>
+    <p:sldId id="282" r:id="rId34"/>
+    <p:sldId id="283" r:id="rId35"/>
   </p:sldIdLst>
   <p:sldSz cx="12191695" cy="6858000" type="screen4x3"/>
   <p:notesSz cx="6858000" cy="9144000"/>
@@ -3820,7 +3822,7 @@
                 <a:ea typeface="Malgun Gothic"/>
                 <a:cs typeface="Malgun Gothic"/>
               </a:rPr>
-              <a:t>전체 15절 가운데 8절</a:t>
+              <a:t>전체 15절 가운데 9절</a:t>
             </a:r>
           </a:p>
           <a:p>
@@ -12221,7 +12223,7 @@
                 <a:ea typeface="Malgun Gothic"/>
                 <a:cs typeface="Malgun Gothic"/>
               </a:rPr>
-              <a:t>REFERENCES   </a:t>
+              <a:t>09   </a:t>
             </a:r>
             <a:r>
               <a:rPr sz="2400" b="1" i="0">
@@ -12232,7 +12234,7 @@
                 <a:ea typeface="Malgun Gothic"/>
                 <a:cs typeface="Malgun Gothic"/>
               </a:rPr>
-              <a:t>참고문헌</a:t>
+              <a:t>9. 근육과 뼈 — 움직임의 역학</a:t>
             </a:r>
           </a:p>
         </p:txBody>
@@ -12280,6 +12282,1272 @@
                 <a:cs typeface="Malgun Gothic"/>
               </a:rPr>
               <a:t>      26</a:t>
+            </a:r>
+          </a:p>
+        </p:txBody>
+      </p:sp>
+      <p:sp>
+        <p:nvSpPr>
+          <p:cNvPr id="7" name="TextBox 6"/>
+          <p:cNvSpPr txBox="1"/>
+          <p:nvPr/>
+        </p:nvSpPr>
+        <p:spPr>
+          <a:xfrm>
+            <a:off x="640080" y="1280160"/>
+            <a:ext cx="10881360" cy="5029200"/>
+          </a:xfrm>
+          <a:prstGeom prst="rect">
+            <a:avLst/>
+          </a:prstGeom>
+          <a:noFill/>
+        </p:spPr>
+        <p:txBody>
+          <a:bodyPr wrap="square" anchor="t">
+            <a:spAutoFit/>
+          </a:bodyPr>
+          <a:lstStyle/>
+          <a:p>
+            <a:pPr>
+              <a:spcAft>
+                <a:spcPts val="900"/>
+              </a:spcAft>
+            </a:pPr>
+            <a:r>
+              <a:rPr sz="1400" b="1" i="0">
+                <a:solidFill>
+                  <a:srgbClr val="F2B705"/>
+                </a:solidFill>
+                <a:latin typeface="Malgun Gothic"/>
+                <a:ea typeface="Malgun Gothic"/>
+                <a:cs typeface="Malgun Gothic"/>
+              </a:rPr>
+              <a:t>•  </a:t>
+            </a:r>
+            <a:r>
+              <a:rPr sz="1400" b="0" i="0">
+                <a:solidFill>
+                  <a:srgbClr val="11202B"/>
+                </a:solidFill>
+                <a:latin typeface="Malgun Gothic"/>
+                <a:ea typeface="Malgun Gothic"/>
+                <a:cs typeface="Malgun Gothic"/>
+              </a:rPr>
+              <a:t>근육이 내는 힘이 곧 몸이 내는 힘은 아니다. 힘은 </a:t>
+            </a:r>
+            <a:r>
+              <a:rPr sz="1400" b="1" i="0">
+                <a:solidFill>
+                  <a:srgbClr val="11202B"/>
+                </a:solidFill>
+                <a:latin typeface="Malgun Gothic"/>
+                <a:ea typeface="Malgun Gothic"/>
+                <a:cs typeface="Malgun Gothic"/>
+              </a:rPr>
+              <a:t>뼈라는 지렛대</a:t>
+            </a:r>
+            <a:r>
+              <a:rPr sz="1400" b="0" i="0">
+                <a:solidFill>
+                  <a:srgbClr val="11202B"/>
+                </a:solidFill>
+                <a:latin typeface="Malgun Gothic"/>
+                <a:ea typeface="Malgun Gothic"/>
+                <a:cs typeface="Malgun Gothic"/>
+              </a:rPr>
+              <a:t>를 통해 전달되며, 그 과정에서 크기와 속도가 교환된다.</a:t>
+            </a:r>
+          </a:p>
+          <a:p>
+            <a:pPr>
+              <a:spcAft>
+                <a:spcPts val="900"/>
+              </a:spcAft>
+            </a:pPr>
+            <a:r>
+              <a:rPr sz="1400" b="1" i="0">
+                <a:solidFill>
+                  <a:srgbClr val="F2B705"/>
+                </a:solidFill>
+                <a:latin typeface="Malgun Gothic"/>
+                <a:ea typeface="Malgun Gothic"/>
+                <a:cs typeface="Malgun Gothic"/>
+              </a:rPr>
+              <a:t>•  </a:t>
+            </a:r>
+            <a:r>
+              <a:rPr sz="1400" b="1" i="0">
+                <a:solidFill>
+                  <a:srgbClr val="11202B"/>
+                </a:solidFill>
+                <a:latin typeface="Malgun Gothic"/>
+                <a:ea typeface="Malgun Gothic"/>
+                <a:cs typeface="Malgun Gothic"/>
+              </a:rPr>
+              <a:t>지렛대의 세 종류.</a:t>
+            </a:r>
+            <a:r>
+              <a:rPr sz="1400" b="0" i="0">
+                <a:solidFill>
+                  <a:srgbClr val="11202B"/>
+                </a:solidFill>
+                <a:latin typeface="Malgun Gothic"/>
+                <a:ea typeface="Malgun Gothic"/>
+                <a:cs typeface="Malgun Gothic"/>
+              </a:rPr>
+              <a:t> 관절이 받침점, 근육이 힘점, 부하가 작용점이다. 셋의 배치에 따라 세 종류로 나뉜다.</a:t>
+            </a:r>
+          </a:p>
+          <a:p>
+            <a:pPr>
+              <a:spcAft>
+                <a:spcPts val="900"/>
+              </a:spcAft>
+            </a:pPr>
+            <a:r>
+              <a:rPr sz="1400" b="1" i="0">
+                <a:solidFill>
+                  <a:srgbClr val="F2B705"/>
+                </a:solidFill>
+                <a:latin typeface="Malgun Gothic"/>
+                <a:ea typeface="Malgun Gothic"/>
+                <a:cs typeface="Malgun Gothic"/>
+              </a:rPr>
+              <a:t>•  </a:t>
+            </a:r>
+            <a:r>
+              <a:rPr sz="1400" b="1" i="0">
+                <a:solidFill>
+                  <a:srgbClr val="11202B"/>
+                </a:solidFill>
+                <a:latin typeface="Malgun Gothic"/>
+                <a:ea typeface="Malgun Gothic"/>
+                <a:cs typeface="Malgun Gothic"/>
+              </a:rPr>
+              <a:t>1종</a:t>
+            </a:r>
+            <a:r>
+              <a:rPr sz="1400" b="0" i="0">
+                <a:solidFill>
+                  <a:srgbClr val="11202B"/>
+                </a:solidFill>
+                <a:latin typeface="Malgun Gothic"/>
+                <a:ea typeface="Malgun Gothic"/>
+                <a:cs typeface="Malgun Gothic"/>
+              </a:rPr>
+              <a:t>: 받침점이 가운데. 목뼈 위에서 머리를 뒤로 젖히는 뒤통수 근육이 그렇다.</a:t>
+            </a:r>
+          </a:p>
+          <a:p>
+            <a:pPr>
+              <a:spcAft>
+                <a:spcPts val="900"/>
+              </a:spcAft>
+            </a:pPr>
+            <a:r>
+              <a:rPr sz="1400" b="1" i="0">
+                <a:solidFill>
+                  <a:srgbClr val="F2B705"/>
+                </a:solidFill>
+                <a:latin typeface="Malgun Gothic"/>
+                <a:ea typeface="Malgun Gothic"/>
+                <a:cs typeface="Malgun Gothic"/>
+              </a:rPr>
+              <a:t>•  </a:t>
+            </a:r>
+            <a:r>
+              <a:rPr sz="1400" b="1" i="0">
+                <a:solidFill>
+                  <a:srgbClr val="11202B"/>
+                </a:solidFill>
+                <a:latin typeface="Malgun Gothic"/>
+                <a:ea typeface="Malgun Gothic"/>
+                <a:cs typeface="Malgun Gothic"/>
+              </a:rPr>
+              <a:t>2종</a:t>
+            </a:r>
+            <a:r>
+              <a:rPr sz="1400" b="0" i="0">
+                <a:solidFill>
+                  <a:srgbClr val="11202B"/>
+                </a:solidFill>
+                <a:latin typeface="Malgun Gothic"/>
+                <a:ea typeface="Malgun Gothic"/>
+                <a:cs typeface="Malgun Gothic"/>
+              </a:rPr>
+              <a:t>: 부하가 가운데. 발끝으로 서는 동작에서 발허리발가락관절이 받침점, 몸무게가 부하, 장딴지근이 힘점이다. 힘에서 이득을 본다.</a:t>
+            </a:r>
+          </a:p>
+          <a:p>
+            <a:pPr>
+              <a:spcAft>
+                <a:spcPts val="900"/>
+              </a:spcAft>
+            </a:pPr>
+            <a:r>
+              <a:rPr sz="1400" b="1" i="0">
+                <a:solidFill>
+                  <a:srgbClr val="F2B705"/>
+                </a:solidFill>
+                <a:latin typeface="Malgun Gothic"/>
+                <a:ea typeface="Malgun Gothic"/>
+                <a:cs typeface="Malgun Gothic"/>
+              </a:rPr>
+              <a:t>•  </a:t>
+            </a:r>
+            <a:r>
+              <a:rPr sz="1400" b="1" i="0">
+                <a:solidFill>
+                  <a:srgbClr val="11202B"/>
+                </a:solidFill>
+                <a:latin typeface="Malgun Gothic"/>
+                <a:ea typeface="Malgun Gothic"/>
+                <a:cs typeface="Malgun Gothic"/>
+              </a:rPr>
+              <a:t>3종</a:t>
+            </a:r>
+            <a:r>
+              <a:rPr sz="1400" b="0" i="0">
+                <a:solidFill>
+                  <a:srgbClr val="11202B"/>
+                </a:solidFill>
+                <a:latin typeface="Malgun Gothic"/>
+                <a:ea typeface="Malgun Gothic"/>
+                <a:cs typeface="Malgun Gothic"/>
+              </a:rPr>
+              <a:t>: 힘점이 가운데. </a:t>
+            </a:r>
+            <a:r>
+              <a:rPr sz="1400" b="1" i="0">
+                <a:solidFill>
+                  <a:srgbClr val="11202B"/>
+                </a:solidFill>
+                <a:latin typeface="Malgun Gothic"/>
+                <a:ea typeface="Malgun Gothic"/>
+                <a:cs typeface="Malgun Gothic"/>
+              </a:rPr>
+              <a:t>몸에서 가장 흔한 형태</a:t>
+            </a:r>
+            <a:r>
+              <a:rPr sz="1400" b="0" i="0">
+                <a:solidFill>
+                  <a:srgbClr val="11202B"/>
+                </a:solidFill>
+                <a:latin typeface="Malgun Gothic"/>
+                <a:ea typeface="Malgun Gothic"/>
+                <a:cs typeface="Malgun Gothic"/>
+              </a:rPr>
+              <a:t>다. 팔꿈치를 굽히는 위팔두갈래근이 전형으로, 근육이 붙는 자리가 관절에 매우 가깝다.</a:t>
+            </a:r>
+          </a:p>
+          <a:p>
+            <a:pPr>
+              <a:spcAft>
+                <a:spcPts val="900"/>
+              </a:spcAft>
+            </a:pPr>
+            <a:r>
+              <a:rPr sz="1400" b="1" i="0">
+                <a:solidFill>
+                  <a:srgbClr val="F2B705"/>
+                </a:solidFill>
+                <a:latin typeface="Malgun Gothic"/>
+                <a:ea typeface="Malgun Gothic"/>
+                <a:cs typeface="Malgun Gothic"/>
+              </a:rPr>
+              <a:t>•  </a:t>
+            </a:r>
+            <a:r>
+              <a:rPr sz="1400" b="0" i="0">
+                <a:solidFill>
+                  <a:srgbClr val="11202B"/>
+                </a:solidFill>
+                <a:latin typeface="Malgun Gothic"/>
+                <a:ea typeface="Malgun Gothic"/>
+                <a:cs typeface="Malgun Gothic"/>
+              </a:rPr>
+              <a:t>3종 지렛대가 흔하다는 사실이 중요한 결과를 낳는다. 근육의 부착점이 관절에 가까우므로 </a:t>
+            </a:r>
+            <a:r>
+              <a:rPr sz="1400" b="1" i="0">
+                <a:solidFill>
+                  <a:srgbClr val="11202B"/>
+                </a:solidFill>
+                <a:latin typeface="Malgun Gothic"/>
+                <a:ea typeface="Malgun Gothic"/>
+                <a:cs typeface="Malgun Gothic"/>
+              </a:rPr>
+              <a:t>모멘트 팔이 짧고</a:t>
+            </a:r>
+            <a:r>
+              <a:rPr sz="1400" b="0" i="0">
+                <a:solidFill>
+                  <a:srgbClr val="11202B"/>
+                </a:solidFill>
+                <a:latin typeface="Malgun Gothic"/>
+                <a:ea typeface="Malgun Gothic"/>
+                <a:cs typeface="Malgun Gothic"/>
+              </a:rPr>
+              <a:t>, 따라서 근육은 부하보다 훨씬 </a:t>
+            </a:r>
+            <a:r>
+              <a:rPr sz="1400" b="1" i="0">
+                <a:solidFill>
+                  <a:srgbClr val="11202B"/>
+                </a:solidFill>
+                <a:latin typeface="Malgun Gothic"/>
+                <a:ea typeface="Malgun Gothic"/>
+                <a:cs typeface="Malgun Gothic"/>
+              </a:rPr>
+              <a:t>큰 힘</a:t>
+            </a:r>
+            <a:r>
+              <a:rPr sz="1400" b="0" i="0">
+                <a:solidFill>
+                  <a:srgbClr val="11202B"/>
+                </a:solidFill>
+                <a:latin typeface="Malgun Gothic"/>
+                <a:ea typeface="Malgun Gothic"/>
+                <a:cs typeface="Malgun Gothic"/>
+              </a:rPr>
+              <a:t>을 내야 한다. 손에 5 kg을 들고 있을 때 위팔두갈래근은 수십 kg에 해당하는 힘을 낸다. 역학적으로는 손해다.</a:t>
+            </a:r>
+          </a:p>
+          <a:p>
+            <a:pPr>
+              <a:spcAft>
+                <a:spcPts val="900"/>
+              </a:spcAft>
+            </a:pPr>
+            <a:r>
+              <a:rPr sz="1400" b="1" i="0">
+                <a:solidFill>
+                  <a:srgbClr val="F2B705"/>
+                </a:solidFill>
+                <a:latin typeface="Malgun Gothic"/>
+                <a:ea typeface="Malgun Gothic"/>
+                <a:cs typeface="Malgun Gothic"/>
+              </a:rPr>
+              <a:t>•  </a:t>
+            </a:r>
+            <a:r>
+              <a:rPr sz="1400" b="0" i="0">
+                <a:solidFill>
+                  <a:srgbClr val="11202B"/>
+                </a:solidFill>
+                <a:latin typeface="Malgun Gothic"/>
+                <a:ea typeface="Malgun Gothic"/>
+                <a:cs typeface="Malgun Gothic"/>
+              </a:rPr>
+              <a:t>그런데 이 설계가 선택된 이유가 있다. 손해를 보는 대신 얻는 것이 </a:t>
+            </a:r>
+            <a:r>
+              <a:rPr sz="1400" b="1" i="0">
+                <a:solidFill>
+                  <a:srgbClr val="11202B"/>
+                </a:solidFill>
+                <a:latin typeface="Malgun Gothic"/>
+                <a:ea typeface="Malgun Gothic"/>
+                <a:cs typeface="Malgun Gothic"/>
+              </a:rPr>
+              <a:t>속도와 운동 범위</a:t>
+            </a:r>
+            <a:r>
+              <a:rPr sz="1400" b="0" i="0">
+                <a:solidFill>
+                  <a:srgbClr val="11202B"/>
+                </a:solidFill>
+                <a:latin typeface="Malgun Gothic"/>
+                <a:ea typeface="Malgun Gothic"/>
+                <a:cs typeface="Malgun Gothic"/>
+              </a:rPr>
+              <a:t>다. 근육이 조금만 짧아져도 손끝은 크게 움직인다. 근육이 1 cm 수축할 때 손은 10 cm 이상 이동한다. 몸이 필요로 한 것은 무거운 것을 천천히 드는 능력이 아니라 </a:t>
+            </a:r>
+            <a:r>
+              <a:rPr sz="1400" b="1" i="0">
+                <a:solidFill>
+                  <a:srgbClr val="11202B"/>
+                </a:solidFill>
+                <a:latin typeface="Malgun Gothic"/>
+                <a:ea typeface="Malgun Gothic"/>
+                <a:cs typeface="Malgun Gothic"/>
+              </a:rPr>
+              <a:t>팔다리를 빠르게 휘두르는 능력</a:t>
+            </a:r>
+            <a:r>
+              <a:rPr sz="1400" b="0" i="0">
+                <a:solidFill>
+                  <a:srgbClr val="11202B"/>
+                </a:solidFill>
+                <a:latin typeface="Malgun Gothic"/>
+                <a:ea typeface="Malgun Gothic"/>
+                <a:cs typeface="Malgun Gothic"/>
+              </a:rPr>
+              <a:t>이었다는 뜻이다.</a:t>
+            </a:r>
+          </a:p>
+          <a:p>
+            <a:pPr>
+              <a:spcAft>
+                <a:spcPts val="900"/>
+              </a:spcAft>
+            </a:pPr>
+            <a:r>
+              <a:rPr sz="1400" b="1" i="0">
+                <a:solidFill>
+                  <a:srgbClr val="F2B705"/>
+                </a:solidFill>
+                <a:latin typeface="Malgun Gothic"/>
+                <a:ea typeface="Malgun Gothic"/>
+                <a:cs typeface="Malgun Gothic"/>
+              </a:rPr>
+              <a:t>•  </a:t>
+            </a:r>
+            <a:r>
+              <a:rPr sz="1400" b="1" i="0">
+                <a:solidFill>
+                  <a:srgbClr val="11202B"/>
+                </a:solidFill>
+                <a:latin typeface="Malgun Gothic"/>
+                <a:ea typeface="Malgun Gothic"/>
+                <a:cs typeface="Malgun Gothic"/>
+              </a:rPr>
+              <a:t>근육의 배열.</a:t>
+            </a:r>
+            <a:r>
+              <a:rPr sz="1400" b="0" i="0">
+                <a:solidFill>
+                  <a:srgbClr val="11202B"/>
+                </a:solidFill>
+                <a:latin typeface="Malgun Gothic"/>
+                <a:ea typeface="Malgun Gothic"/>
+                <a:cs typeface="Malgun Gothic"/>
+              </a:rPr>
+              <a:t> 같은 부피의 근육이라도 섬유의 배열에 따라 성질이 달라진다.</a:t>
+            </a:r>
+          </a:p>
+          <a:p>
+            <a:pPr>
+              <a:spcAft>
+                <a:spcPts val="900"/>
+              </a:spcAft>
+            </a:pPr>
+            <a:r>
+              <a:rPr sz="1400" b="1" i="0">
+                <a:solidFill>
+                  <a:srgbClr val="F2B705"/>
+                </a:solidFill>
+                <a:latin typeface="Malgun Gothic"/>
+                <a:ea typeface="Malgun Gothic"/>
+                <a:cs typeface="Malgun Gothic"/>
+              </a:rPr>
+              <a:t>•  </a:t>
+            </a:r>
+            <a:r>
+              <a:rPr sz="1400" b="1" i="0">
+                <a:solidFill>
+                  <a:srgbClr val="11202B"/>
+                </a:solidFill>
+                <a:latin typeface="Malgun Gothic"/>
+                <a:ea typeface="Malgun Gothic"/>
+                <a:cs typeface="Malgun Gothic"/>
+              </a:rPr>
+              <a:t>평행 배열</a:t>
+            </a:r>
+            <a:r>
+              <a:rPr sz="1400" b="0" i="0">
+                <a:solidFill>
+                  <a:srgbClr val="11202B"/>
+                </a:solidFill>
+                <a:latin typeface="Malgun Gothic"/>
+                <a:ea typeface="Malgun Gothic"/>
+                <a:cs typeface="Malgun Gothic"/>
+              </a:rPr>
+              <a:t>: 섬유가 근육의 긴 축과 나란하다. 섬유가 길어 </a:t>
+            </a:r>
+            <a:r>
+              <a:rPr sz="1400" b="1" i="0">
+                <a:solidFill>
+                  <a:srgbClr val="11202B"/>
+                </a:solidFill>
+                <a:latin typeface="Malgun Gothic"/>
+                <a:ea typeface="Malgun Gothic"/>
+                <a:cs typeface="Malgun Gothic"/>
+              </a:rPr>
+              <a:t>수축 거리와 속도</a:t>
+            </a:r>
+            <a:r>
+              <a:rPr sz="1400" b="0" i="0">
+                <a:solidFill>
+                  <a:srgbClr val="11202B"/>
+                </a:solidFill>
+                <a:latin typeface="Malgun Gothic"/>
+                <a:ea typeface="Malgun Gothic"/>
+                <a:cs typeface="Malgun Gothic"/>
+              </a:rPr>
+              <a:t>에서 유리하다. 넙다리빗근이 그렇다.</a:t>
+            </a:r>
+          </a:p>
+          <a:p>
+            <a:pPr>
+              <a:spcAft>
+                <a:spcPts val="900"/>
+              </a:spcAft>
+            </a:pPr>
+            <a:r>
+              <a:rPr sz="1400" b="1" i="0">
+                <a:solidFill>
+                  <a:srgbClr val="F2B705"/>
+                </a:solidFill>
+                <a:latin typeface="Malgun Gothic"/>
+                <a:ea typeface="Malgun Gothic"/>
+                <a:cs typeface="Malgun Gothic"/>
+              </a:rPr>
+              <a:t>•  </a:t>
+            </a:r>
+            <a:r>
+              <a:rPr sz="1400" b="1" i="0">
+                <a:solidFill>
+                  <a:srgbClr val="11202B"/>
+                </a:solidFill>
+                <a:latin typeface="Malgun Gothic"/>
+                <a:ea typeface="Malgun Gothic"/>
+                <a:cs typeface="Malgun Gothic"/>
+              </a:rPr>
+              <a:t>깃 배열(pennate)</a:t>
+            </a:r>
+            <a:r>
+              <a:rPr sz="1400" b="0" i="0">
+                <a:solidFill>
+                  <a:srgbClr val="11202B"/>
+                </a:solidFill>
+                <a:latin typeface="Malgun Gothic"/>
+                <a:ea typeface="Malgun Gothic"/>
+                <a:cs typeface="Malgun Gothic"/>
+              </a:rPr>
+              <a:t>: 섬유가 힘줄에 비스듬히 붙는다. 같은 부피에 더 많은 섬유를 채울 수 있어 </a:t>
+            </a:r>
+            <a:r>
+              <a:rPr sz="1400" b="1" i="0">
+                <a:solidFill>
+                  <a:srgbClr val="11202B"/>
+                </a:solidFill>
+                <a:latin typeface="Malgun Gothic"/>
+                <a:ea typeface="Malgun Gothic"/>
+                <a:cs typeface="Malgun Gothic"/>
+              </a:rPr>
+              <a:t>생리적 단면적이 커지고 힘</a:t>
+            </a:r>
+            <a:r>
+              <a:rPr sz="1400" b="0" i="0">
+                <a:solidFill>
+                  <a:srgbClr val="11202B"/>
+                </a:solidFill>
+                <a:latin typeface="Malgun Gothic"/>
+                <a:ea typeface="Malgun Gothic"/>
+                <a:cs typeface="Malgun Gothic"/>
+              </a:rPr>
+              <a:t>에서 유리하다. 대신 섬유가 짧아 수축 거리가 줄고, 비스듬한 각도 때문에 힘의 일부가 손실된다. 넙다리곧은근과 장딴지근이 그렇다.</a:t>
+            </a:r>
+          </a:p>
+          <a:p>
+            <a:pPr>
+              <a:spcAft>
+                <a:spcPts val="900"/>
+              </a:spcAft>
+            </a:pPr>
+            <a:r>
+              <a:rPr sz="1400" b="1" i="0">
+                <a:solidFill>
+                  <a:srgbClr val="F2B705"/>
+                </a:solidFill>
+                <a:latin typeface="Malgun Gothic"/>
+                <a:ea typeface="Malgun Gothic"/>
+                <a:cs typeface="Malgun Gothic"/>
+              </a:rPr>
+              <a:t>•  </a:t>
+            </a:r>
+            <a:r>
+              <a:rPr sz="1400" b="0" i="0">
+                <a:solidFill>
+                  <a:srgbClr val="11202B"/>
+                </a:solidFill>
+                <a:latin typeface="Malgun Gothic"/>
+                <a:ea typeface="Malgun Gothic"/>
+                <a:cs typeface="Malgun Gothic"/>
+              </a:rPr>
+              <a:t>근육이 내는 최대 힘은 부피가 아니라 </a:t>
+            </a:r>
+            <a:r>
+              <a:rPr sz="1400" b="1" i="0">
+                <a:solidFill>
+                  <a:srgbClr val="11202B"/>
+                </a:solidFill>
+                <a:latin typeface="Malgun Gothic"/>
+                <a:ea typeface="Malgun Gothic"/>
+                <a:cs typeface="Malgun Gothic"/>
+              </a:rPr>
+              <a:t>생리적 단면적</a:t>
+            </a:r>
+            <a:r>
+              <a:rPr sz="1400" b="0" i="0">
+                <a:solidFill>
+                  <a:srgbClr val="11202B"/>
+                </a:solidFill>
+                <a:latin typeface="Malgun Gothic"/>
+                <a:ea typeface="Malgun Gothic"/>
+                <a:cs typeface="Malgun Gothic"/>
+              </a:rPr>
+              <a:t>, 즉 모든 섬유를 가로지르는 단면의 합에 비례한다. 깃 배열이 힘에서 유리한 이유가 이 때문이다.</a:t>
+            </a:r>
+          </a:p>
+          <a:p>
+            <a:pPr>
+              <a:spcAft>
+                <a:spcPts val="900"/>
+              </a:spcAft>
+            </a:pPr>
+            <a:r>
+              <a:rPr sz="1400" b="1" i="0">
+                <a:solidFill>
+                  <a:srgbClr val="F2B705"/>
+                </a:solidFill>
+                <a:latin typeface="Malgun Gothic"/>
+                <a:ea typeface="Malgun Gothic"/>
+                <a:cs typeface="Malgun Gothic"/>
+              </a:rPr>
+              <a:t>•  </a:t>
+            </a:r>
+            <a:r>
+              <a:rPr sz="1400" b="1" i="0">
+                <a:solidFill>
+                  <a:srgbClr val="11202B"/>
+                </a:solidFill>
+                <a:latin typeface="Malgun Gothic"/>
+                <a:ea typeface="Malgun Gothic"/>
+                <a:cs typeface="Malgun Gothic"/>
+              </a:rPr>
+              <a:t>관절 각도와 힘.</a:t>
+            </a:r>
+            <a:r>
+              <a:rPr sz="1400" b="0" i="0">
+                <a:solidFill>
+                  <a:srgbClr val="11202B"/>
+                </a:solidFill>
+                <a:latin typeface="Malgun Gothic"/>
+                <a:ea typeface="Malgun Gothic"/>
+                <a:cs typeface="Malgun Gothic"/>
+              </a:rPr>
+              <a:t> 같은 근육이라도 관절 각도에 따라 낼 수 있는 토크가 달라진다. 두 요인이 겹친다. 하나는 7절의 길이–장력 관계로, 각도에 따라 sarcomere 길이가 달라진다. 다른 하나는 모멘트 팔로, 각도에 따라 힘이 작용하는 지렛대의 길이가 달라진다. 두 곡선의 곱이 실제 토크 곡선이며, 그래서 팔씨름이나 역도에서 특정 각도에서 유독 힘이 약해지는 구간이 생긴다.</a:t>
+            </a:r>
+          </a:p>
+        </p:txBody>
+      </p:sp>
+    </p:spTree>
+  </p:cSld>
+  <p:clrMapOvr>
+    <a:masterClrMapping/>
+  </p:clrMapOvr>
+</p:sld>
+</file>
+
+<file path=ppt/slides/slide27.xml><?xml version="1.0" encoding="utf-8"?>
+<p:sld xmlns:a="http://schemas.openxmlformats.org/drawingml/2006/main" xmlns:p="http://schemas.openxmlformats.org/presentationml/2006/main" xmlns:r="http://schemas.openxmlformats.org/officeDocument/2006/relationships">
+  <p:cSld>
+    <p:spTree>
+      <p:nvGrpSpPr>
+        <p:cNvPr id="1" name=""/>
+        <p:cNvGrpSpPr/>
+        <p:nvPr/>
+      </p:nvGrpSpPr>
+      <p:grpSpPr/>
+      <p:sp>
+        <p:nvSpPr>
+          <p:cNvPr id="2" name="Rectangle 1"/>
+          <p:cNvSpPr/>
+          <p:nvPr/>
+        </p:nvSpPr>
+        <p:spPr>
+          <a:xfrm>
+            <a:off x="0" y="0"/>
+            <a:ext cx="12191695" cy="6858000"/>
+          </a:xfrm>
+          <a:prstGeom prst="rect">
+            <a:avLst/>
+          </a:prstGeom>
+          <a:solidFill>
+            <a:srgbClr val="F5F8F9"/>
+          </a:solidFill>
+          <a:ln>
+            <a:noFill/>
+          </a:ln>
+          <a:effectLst/>
+        </p:spPr>
+        <p:style>
+          <a:lnRef idx="1">
+            <a:schemeClr val="accent1"/>
+          </a:lnRef>
+          <a:fillRef idx="3">
+            <a:schemeClr val="accent1"/>
+          </a:fillRef>
+          <a:effectRef idx="2">
+            <a:schemeClr val="accent1"/>
+          </a:effectRef>
+          <a:fontRef idx="minor">
+            <a:schemeClr val="lt1"/>
+          </a:fontRef>
+        </p:style>
+        <p:txBody>
+          <a:bodyPr rtlCol="0" anchor="ctr"/>
+          <a:lstStyle/>
+          <a:p>
+            <a:pPr algn="ctr"/>
+          </a:p>
+        </p:txBody>
+      </p:sp>
+      <p:sp>
+        <p:nvSpPr>
+          <p:cNvPr id="3" name="Rectangle 2"/>
+          <p:cNvSpPr/>
+          <p:nvPr/>
+        </p:nvSpPr>
+        <p:spPr>
+          <a:xfrm>
+            <a:off x="0" y="0"/>
+            <a:ext cx="12191695" cy="960120"/>
+          </a:xfrm>
+          <a:prstGeom prst="rect">
+            <a:avLst/>
+          </a:prstGeom>
+          <a:solidFill>
+            <a:srgbClr val="003C71"/>
+          </a:solidFill>
+          <a:ln>
+            <a:noFill/>
+          </a:ln>
+          <a:effectLst/>
+        </p:spPr>
+        <p:style>
+          <a:lnRef idx="1">
+            <a:schemeClr val="accent1"/>
+          </a:lnRef>
+          <a:fillRef idx="3">
+            <a:schemeClr val="accent1"/>
+          </a:fillRef>
+          <a:effectRef idx="2">
+            <a:schemeClr val="accent1"/>
+          </a:effectRef>
+          <a:fontRef idx="minor">
+            <a:schemeClr val="lt1"/>
+          </a:fontRef>
+        </p:style>
+        <p:txBody>
+          <a:bodyPr rtlCol="0" anchor="ctr"/>
+          <a:lstStyle/>
+          <a:p>
+            <a:pPr algn="ctr"/>
+          </a:p>
+        </p:txBody>
+      </p:sp>
+      <p:sp>
+        <p:nvSpPr>
+          <p:cNvPr id="4" name="Rectangle 3"/>
+          <p:cNvSpPr/>
+          <p:nvPr/>
+        </p:nvSpPr>
+        <p:spPr>
+          <a:xfrm>
+            <a:off x="0" y="960120"/>
+            <a:ext cx="12191695" cy="54864"/>
+          </a:xfrm>
+          <a:prstGeom prst="rect">
+            <a:avLst/>
+          </a:prstGeom>
+          <a:solidFill>
+            <a:srgbClr val="F2B705"/>
+          </a:solidFill>
+          <a:ln>
+            <a:noFill/>
+          </a:ln>
+          <a:effectLst/>
+        </p:spPr>
+        <p:style>
+          <a:lnRef idx="1">
+            <a:schemeClr val="accent1"/>
+          </a:lnRef>
+          <a:fillRef idx="3">
+            <a:schemeClr val="accent1"/>
+          </a:fillRef>
+          <a:effectRef idx="2">
+            <a:schemeClr val="accent1"/>
+          </a:effectRef>
+          <a:fontRef idx="minor">
+            <a:schemeClr val="lt1"/>
+          </a:fontRef>
+        </p:style>
+        <p:txBody>
+          <a:bodyPr rtlCol="0" anchor="ctr"/>
+          <a:lstStyle/>
+          <a:p>
+            <a:pPr algn="ctr"/>
+          </a:p>
+        </p:txBody>
+      </p:sp>
+      <p:sp>
+        <p:nvSpPr>
+          <p:cNvPr id="5" name="TextBox 4"/>
+          <p:cNvSpPr txBox="1"/>
+          <p:nvPr/>
+        </p:nvSpPr>
+        <p:spPr>
+          <a:xfrm>
+            <a:off x="457200" y="109728"/>
+            <a:ext cx="11247120" cy="777240"/>
+          </a:xfrm>
+          <a:prstGeom prst="rect">
+            <a:avLst/>
+          </a:prstGeom>
+          <a:noFill/>
+        </p:spPr>
+        <p:txBody>
+          <a:bodyPr wrap="square" anchor="ctr">
+            <a:spAutoFit/>
+          </a:bodyPr>
+          <a:lstStyle/>
+          <a:p>
+            <a:r>
+              <a:rPr sz="1300" b="1" i="0">
+                <a:solidFill>
+                  <a:srgbClr val="F2B705"/>
+                </a:solidFill>
+                <a:latin typeface="Malgun Gothic"/>
+                <a:ea typeface="Malgun Gothic"/>
+                <a:cs typeface="Malgun Gothic"/>
+              </a:rPr>
+              <a:t>09   </a:t>
+            </a:r>
+            <a:r>
+              <a:rPr sz="2400" b="1" i="0">
+                <a:solidFill>
+                  <a:srgbClr val="FFFFFF"/>
+                </a:solidFill>
+                <a:latin typeface="Malgun Gothic"/>
+                <a:ea typeface="Malgun Gothic"/>
+                <a:cs typeface="Malgun Gothic"/>
+              </a:rPr>
+              <a:t>9. 근육과 뼈 — 움직임의 역학</a:t>
+            </a:r>
+          </a:p>
+        </p:txBody>
+      </p:sp>
+      <p:sp>
+        <p:nvSpPr>
+          <p:cNvPr id="6" name="TextBox 5"/>
+          <p:cNvSpPr txBox="1"/>
+          <p:nvPr/>
+        </p:nvSpPr>
+        <p:spPr>
+          <a:xfrm>
+            <a:off x="457200" y="6446520"/>
+            <a:ext cx="11247120" cy="301752"/>
+          </a:xfrm>
+          <a:prstGeom prst="rect">
+            <a:avLst/>
+          </a:prstGeom>
+          <a:noFill/>
+        </p:spPr>
+        <p:txBody>
+          <a:bodyPr wrap="square" anchor="ctr">
+            <a:spAutoFit/>
+          </a:bodyPr>
+          <a:lstStyle/>
+          <a:p>
+            <a:r>
+              <a:rPr sz="900" b="0" i="0">
+                <a:solidFill>
+                  <a:srgbClr val="66788A"/>
+                </a:solidFill>
+                <a:latin typeface="Malgun Gothic"/>
+                <a:ea typeface="Malgun Gothic"/>
+                <a:cs typeface="Malgun Gothic"/>
+              </a:rPr>
+              <a:t>M01-W03-L03  ·  근육 요약: 근육 유형·수축·운동</a:t>
+            </a:r>
+            <a:r>
+              <a:rPr sz="900" b="1" i="0">
+                <a:solidFill>
+                  <a:srgbClr val="003C71"/>
+                </a:solidFill>
+                <a:latin typeface="Malgun Gothic"/>
+                <a:ea typeface="Malgun Gothic"/>
+                <a:cs typeface="Malgun Gothic"/>
+              </a:rPr>
+              <a:t>      27</a:t>
+            </a:r>
+          </a:p>
+        </p:txBody>
+      </p:sp>
+      <p:sp>
+        <p:nvSpPr>
+          <p:cNvPr id="7" name="Rectangle 6"/>
+          <p:cNvSpPr/>
+          <p:nvPr/>
+        </p:nvSpPr>
+        <p:spPr>
+          <a:xfrm>
+            <a:off x="640080" y="1325880"/>
+            <a:ext cx="10881360" cy="1681480"/>
+          </a:xfrm>
+          <a:prstGeom prst="rect">
+            <a:avLst/>
+          </a:prstGeom>
+          <a:solidFill>
+            <a:srgbClr val="ECF6EC"/>
+          </a:solidFill>
+          <a:ln>
+            <a:noFill/>
+          </a:ln>
+          <a:effectLst/>
+        </p:spPr>
+        <p:style>
+          <a:lnRef idx="1">
+            <a:schemeClr val="accent1"/>
+          </a:lnRef>
+          <a:fillRef idx="3">
+            <a:schemeClr val="accent1"/>
+          </a:fillRef>
+          <a:effectRef idx="2">
+            <a:schemeClr val="accent1"/>
+          </a:effectRef>
+          <a:fontRef idx="minor">
+            <a:schemeClr val="lt1"/>
+          </a:fontRef>
+        </p:style>
+        <p:txBody>
+          <a:bodyPr rtlCol="0" anchor="ctr" wrap="square" lIns="228600" rIns="228600"/>
+          <a:lstStyle/>
+          <a:p>
+            <a:pPr algn="l"/>
+            <a:r>
+              <a:rPr sz="1200" b="1" i="0">
+                <a:solidFill>
+                  <a:srgbClr val="1E6B2C"/>
+                </a:solidFill>
+                <a:latin typeface="Malgun Gothic"/>
+                <a:ea typeface="Malgun Gothic"/>
+                <a:cs typeface="Malgun Gothic"/>
+              </a:rPr>
+              <a:t>시험에서 가려내는 지점   </a:t>
+            </a:r>
+            <a:r>
+              <a:rPr sz="1600" b="1" i="0">
+                <a:solidFill>
+                  <a:srgbClr val="11202B"/>
+                </a:solidFill>
+                <a:latin typeface="Malgun Gothic"/>
+                <a:ea typeface="Malgun Gothic"/>
+                <a:cs typeface="Malgun Gothic"/>
+              </a:rPr>
+              <a:t>시험에서 가려내는 지점</a:t>
+            </a:r>
+            <a:r>
+              <a:rPr sz="1600" b="0" i="0">
+                <a:solidFill>
+                  <a:srgbClr val="11202B"/>
+                </a:solidFill>
+                <a:latin typeface="Malgun Gothic"/>
+                <a:ea typeface="Malgun Gothic"/>
+                <a:cs typeface="Malgun Gothic"/>
+              </a:rPr>
+              <a:t> 근육의 작용을 외울 때는 </a:t>
+            </a:r>
+            <a:r>
+              <a:rPr sz="1600" b="1" i="0">
+                <a:solidFill>
+                  <a:srgbClr val="11202B"/>
+                </a:solidFill>
+                <a:latin typeface="Malgun Gothic"/>
+                <a:ea typeface="Malgun Gothic"/>
+                <a:cs typeface="Malgun Gothic"/>
+              </a:rPr>
+              <a:t>힘줄이 관절 축의 어느 쪽을 지나는가</a:t>
+            </a:r>
+            <a:r>
+              <a:rPr sz="1600" b="0" i="0">
+                <a:solidFill>
+                  <a:srgbClr val="11202B"/>
+                </a:solidFill>
+                <a:latin typeface="Malgun Gothic"/>
+                <a:ea typeface="Malgun Gothic"/>
+                <a:cs typeface="Malgun Gothic"/>
+              </a:rPr>
+              <a:t>를 보면 된다. 관절 축의 앞을 지나면 굽히고 뒤를 지나면 편다. 이 원리로 두 관절을 지나는 근육(이관절근)의 작용도 예측된다. 넙다리두갈래근은 엉덩관절 뒤와 무릎 뒤를 지나므로 엉덩관절을 펴고 무릎을 굽힌다. 또 이관절근은 한 관절에서 짧아지는 동안 다른 관절에서 늘어날 수 있어 </a:t>
+            </a:r>
+            <a:r>
+              <a:rPr sz="1600" b="1" i="0">
+                <a:solidFill>
+                  <a:srgbClr val="11202B"/>
+                </a:solidFill>
+                <a:latin typeface="Malgun Gothic"/>
+                <a:ea typeface="Malgun Gothic"/>
+                <a:cs typeface="Malgun Gothic"/>
+              </a:rPr>
+              <a:t>전체 길이 변화가 작게 유지</a:t>
+            </a:r>
+            <a:r>
+              <a:rPr sz="1600" b="0" i="0">
+                <a:solidFill>
+                  <a:srgbClr val="11202B"/>
+                </a:solidFill>
+                <a:latin typeface="Malgun Gothic"/>
+                <a:ea typeface="Malgun Gothic"/>
+                <a:cs typeface="Malgun Gothic"/>
+              </a:rPr>
+              <a:t>되며, 길이–장력 곡선의 유리한 구간에 머물 수 있다. 걷기와 달리기에서 에너지 효율이 높은 이유 가운데 하나다.</a:t>
+            </a:r>
+          </a:p>
+        </p:txBody>
+      </p:sp>
+    </p:spTree>
+  </p:cSld>
+  <p:clrMapOvr>
+    <a:masterClrMapping/>
+  </p:clrMapOvr>
+</p:sld>
+</file>
+
+<file path=ppt/slides/slide28.xml><?xml version="1.0" encoding="utf-8"?>
+<p:sld xmlns:a="http://schemas.openxmlformats.org/drawingml/2006/main" xmlns:p="http://schemas.openxmlformats.org/presentationml/2006/main" xmlns:r="http://schemas.openxmlformats.org/officeDocument/2006/relationships">
+  <p:cSld>
+    <p:spTree>
+      <p:nvGrpSpPr>
+        <p:cNvPr id="1" name=""/>
+        <p:cNvGrpSpPr/>
+        <p:nvPr/>
+      </p:nvGrpSpPr>
+      <p:grpSpPr/>
+      <p:sp>
+        <p:nvSpPr>
+          <p:cNvPr id="2" name="Rectangle 1"/>
+          <p:cNvSpPr/>
+          <p:nvPr/>
+        </p:nvSpPr>
+        <p:spPr>
+          <a:xfrm>
+            <a:off x="0" y="0"/>
+            <a:ext cx="12191695" cy="6858000"/>
+          </a:xfrm>
+          <a:prstGeom prst="rect">
+            <a:avLst/>
+          </a:prstGeom>
+          <a:solidFill>
+            <a:srgbClr val="F5F8F9"/>
+          </a:solidFill>
+          <a:ln>
+            <a:noFill/>
+          </a:ln>
+          <a:effectLst/>
+        </p:spPr>
+        <p:style>
+          <a:lnRef idx="1">
+            <a:schemeClr val="accent1"/>
+          </a:lnRef>
+          <a:fillRef idx="3">
+            <a:schemeClr val="accent1"/>
+          </a:fillRef>
+          <a:effectRef idx="2">
+            <a:schemeClr val="accent1"/>
+          </a:effectRef>
+          <a:fontRef idx="minor">
+            <a:schemeClr val="lt1"/>
+          </a:fontRef>
+        </p:style>
+        <p:txBody>
+          <a:bodyPr rtlCol="0" anchor="ctr"/>
+          <a:lstStyle/>
+          <a:p>
+            <a:pPr algn="ctr"/>
+          </a:p>
+        </p:txBody>
+      </p:sp>
+      <p:sp>
+        <p:nvSpPr>
+          <p:cNvPr id="3" name="Rectangle 2"/>
+          <p:cNvSpPr/>
+          <p:nvPr/>
+        </p:nvSpPr>
+        <p:spPr>
+          <a:xfrm>
+            <a:off x="0" y="0"/>
+            <a:ext cx="12191695" cy="960120"/>
+          </a:xfrm>
+          <a:prstGeom prst="rect">
+            <a:avLst/>
+          </a:prstGeom>
+          <a:solidFill>
+            <a:srgbClr val="003C71"/>
+          </a:solidFill>
+          <a:ln>
+            <a:noFill/>
+          </a:ln>
+          <a:effectLst/>
+        </p:spPr>
+        <p:style>
+          <a:lnRef idx="1">
+            <a:schemeClr val="accent1"/>
+          </a:lnRef>
+          <a:fillRef idx="3">
+            <a:schemeClr val="accent1"/>
+          </a:fillRef>
+          <a:effectRef idx="2">
+            <a:schemeClr val="accent1"/>
+          </a:effectRef>
+          <a:fontRef idx="minor">
+            <a:schemeClr val="lt1"/>
+          </a:fontRef>
+        </p:style>
+        <p:txBody>
+          <a:bodyPr rtlCol="0" anchor="ctr"/>
+          <a:lstStyle/>
+          <a:p>
+            <a:pPr algn="ctr"/>
+          </a:p>
+        </p:txBody>
+      </p:sp>
+      <p:sp>
+        <p:nvSpPr>
+          <p:cNvPr id="4" name="Rectangle 3"/>
+          <p:cNvSpPr/>
+          <p:nvPr/>
+        </p:nvSpPr>
+        <p:spPr>
+          <a:xfrm>
+            <a:off x="0" y="960120"/>
+            <a:ext cx="12191695" cy="54864"/>
+          </a:xfrm>
+          <a:prstGeom prst="rect">
+            <a:avLst/>
+          </a:prstGeom>
+          <a:solidFill>
+            <a:srgbClr val="F2B705"/>
+          </a:solidFill>
+          <a:ln>
+            <a:noFill/>
+          </a:ln>
+          <a:effectLst/>
+        </p:spPr>
+        <p:style>
+          <a:lnRef idx="1">
+            <a:schemeClr val="accent1"/>
+          </a:lnRef>
+          <a:fillRef idx="3">
+            <a:schemeClr val="accent1"/>
+          </a:fillRef>
+          <a:effectRef idx="2">
+            <a:schemeClr val="accent1"/>
+          </a:effectRef>
+          <a:fontRef idx="minor">
+            <a:schemeClr val="lt1"/>
+          </a:fontRef>
+        </p:style>
+        <p:txBody>
+          <a:bodyPr rtlCol="0" anchor="ctr"/>
+          <a:lstStyle/>
+          <a:p>
+            <a:pPr algn="ctr"/>
+          </a:p>
+        </p:txBody>
+      </p:sp>
+      <p:sp>
+        <p:nvSpPr>
+          <p:cNvPr id="5" name="TextBox 4"/>
+          <p:cNvSpPr txBox="1"/>
+          <p:nvPr/>
+        </p:nvSpPr>
+        <p:spPr>
+          <a:xfrm>
+            <a:off x="457200" y="109728"/>
+            <a:ext cx="11247120" cy="777240"/>
+          </a:xfrm>
+          <a:prstGeom prst="rect">
+            <a:avLst/>
+          </a:prstGeom>
+          <a:noFill/>
+        </p:spPr>
+        <p:txBody>
+          <a:bodyPr wrap="square" anchor="ctr">
+            <a:spAutoFit/>
+          </a:bodyPr>
+          <a:lstStyle/>
+          <a:p>
+            <a:r>
+              <a:rPr sz="1300" b="1" i="0">
+                <a:solidFill>
+                  <a:srgbClr val="F2B705"/>
+                </a:solidFill>
+                <a:latin typeface="Malgun Gothic"/>
+                <a:ea typeface="Malgun Gothic"/>
+                <a:cs typeface="Malgun Gothic"/>
+              </a:rPr>
+              <a:t>REFERENCES   </a:t>
+            </a:r>
+            <a:r>
+              <a:rPr sz="2400" b="1" i="0">
+                <a:solidFill>
+                  <a:srgbClr val="FFFFFF"/>
+                </a:solidFill>
+                <a:latin typeface="Malgun Gothic"/>
+                <a:ea typeface="Malgun Gothic"/>
+                <a:cs typeface="Malgun Gothic"/>
+              </a:rPr>
+              <a:t>참고문헌</a:t>
+            </a:r>
+          </a:p>
+        </p:txBody>
+      </p:sp>
+      <p:sp>
+        <p:nvSpPr>
+          <p:cNvPr id="6" name="TextBox 5"/>
+          <p:cNvSpPr txBox="1"/>
+          <p:nvPr/>
+        </p:nvSpPr>
+        <p:spPr>
+          <a:xfrm>
+            <a:off x="457200" y="6446520"/>
+            <a:ext cx="11247120" cy="301752"/>
+          </a:xfrm>
+          <a:prstGeom prst="rect">
+            <a:avLst/>
+          </a:prstGeom>
+          <a:noFill/>
+        </p:spPr>
+        <p:txBody>
+          <a:bodyPr wrap="square" anchor="ctr">
+            <a:spAutoFit/>
+          </a:bodyPr>
+          <a:lstStyle/>
+          <a:p>
+            <a:r>
+              <a:rPr sz="900" b="0" i="0">
+                <a:solidFill>
+                  <a:srgbClr val="66788A"/>
+                </a:solidFill>
+                <a:latin typeface="Malgun Gothic"/>
+                <a:ea typeface="Malgun Gothic"/>
+                <a:cs typeface="Malgun Gothic"/>
+              </a:rPr>
+              <a:t>M01-W03-L03  ·  근육 요약: 근육 유형·수축·운동</a:t>
+            </a:r>
+            <a:r>
+              <a:rPr sz="900" b="1" i="0">
+                <a:solidFill>
+                  <a:srgbClr val="003C71"/>
+                </a:solidFill>
+                <a:latin typeface="Malgun Gothic"/>
+                <a:ea typeface="Malgun Gothic"/>
+                <a:cs typeface="Malgun Gothic"/>
+              </a:rPr>
+              <a:t>      28</a:t>
             </a:r>
           </a:p>
         </p:txBody>
@@ -13388,6 +14656,35 @@
                 <a:cs typeface="Malgun Gothic"/>
               </a:rPr>
               <a:t>8. 수축의 역학</a:t>
+            </a:r>
+          </a:p>
+          <a:p>
+            <a:pPr>
+              <a:spcAft>
+                <a:spcPts val="900"/>
+              </a:spcAft>
+            </a:pPr>
+            <a:r>
+              <a:rPr sz="2000" b="1" i="0">
+                <a:solidFill>
+                  <a:srgbClr val="F2B705"/>
+                </a:solidFill>
+                <a:latin typeface="Malgun Gothic"/>
+                <a:ea typeface="Malgun Gothic"/>
+                <a:cs typeface="Malgun Gothic"/>
+              </a:rPr>
+              <a:t>9.  </a:t>
+            </a:r>
+            <a:r>
+              <a:rPr sz="2000" b="0" i="0">
+                <a:solidFill>
+                  <a:srgbClr val="11202B"/>
+                </a:solidFill>
+                <a:latin typeface="Malgun Gothic"/>
+                <a:ea typeface="Malgun Gothic"/>
+                <a:cs typeface="Malgun Gothic"/>
+              </a:rPr>
+              <a:t>9. 근육과 뼈 — 움직임의 역학</a:t>
             </a:r>
           </a:p>
         </p:txBody>

</xml_diff>